<commit_message>
Release v1.5.0: algorithmic QC outputs and author synchronization
</commit_message>
<xml_diff>
--- a/outputs/figures/Figure_1_Cohort_and_infusion_flow.pptx
+++ b/outputs/figures/Figure_1_Cohort_and_infusion_flow.pptx
@@ -10,7 +10,7 @@
   <p:sldIdLst>
     <p:sldId xmlns:r="http://schemas.openxmlformats.org/officeDocument/2006/relationships" id="256" r:id="Rf463983ae7694034"/>
   </p:sldIdLst>
-  <p:sldSz cx="5981700" cy="6477000"/>
+  <p:sldSz cx="5981700" cy="6837000"/>
   <p:notesSz cx="6858000" cy="9144000"/>
 </p:presentation>
 </file>
@@ -1072,7 +1072,7 @@
         </p:nvSpPr>
         <p:spPr>
           <a:xfrm xmlns:a="http://schemas.openxmlformats.org/drawingml/2006/main">
-            <a:off x="76200" y="38100"/>
+            <a:off x="76200" y="398100"/>
             <a:ext cx="2857500" cy="285750"/>
           </a:xfrm>
           <a:prstGeom xmlns:a="http://schemas.openxmlformats.org/drawingml/2006/main" prst="rect">
@@ -1129,7 +1129,7 @@
         </p:nvSpPr>
         <p:spPr>
           <a:xfrm xmlns:a="http://schemas.openxmlformats.org/drawingml/2006/main">
-            <a:off x="3133725" y="38100"/>
+            <a:off x="3133725" y="398100"/>
             <a:ext cx="2762250" cy="285750"/>
           </a:xfrm>
           <a:prstGeom xmlns:a="http://schemas.openxmlformats.org/drawingml/2006/main" prst="rect">
@@ -1186,7 +1186,7 @@
         </p:nvSpPr>
         <p:spPr>
           <a:xfrm xmlns:a="http://schemas.openxmlformats.org/drawingml/2006/main">
-            <a:off x="95250" y="552450"/>
+            <a:off x="95250" y="912450"/>
             <a:ext cx="2714625" cy="447675"/>
           </a:xfrm>
           <a:prstGeom xmlns:a="http://schemas.openxmlformats.org/drawingml/2006/main" prst="rect">
@@ -1218,7 +1218,7 @@
         </p:nvSpPr>
         <p:spPr>
           <a:xfrm xmlns:a="http://schemas.openxmlformats.org/drawingml/2006/main">
-            <a:off x="161925" y="581025"/>
+            <a:off x="161925" y="941025"/>
             <a:ext cx="2581275" cy="381000"/>
           </a:xfrm>
           <a:prstGeom xmlns:a="http://schemas.openxmlformats.org/drawingml/2006/main" prst="rect">
@@ -1298,7 +1298,7 @@
         </p:nvSpPr>
         <p:spPr>
           <a:xfrm xmlns:a="http://schemas.openxmlformats.org/drawingml/2006/main">
-            <a:off x="1428750" y="1000125"/>
+            <a:off x="1428750" y="1360125"/>
             <a:ext cx="9525" cy="361950"/>
           </a:xfrm>
           <a:prstGeom xmlns:a="http://schemas.openxmlformats.org/drawingml/2006/main" prst="rect">
@@ -1328,7 +1328,7 @@
         </p:nvSpPr>
         <p:spPr>
           <a:xfrm xmlns:a="http://schemas.openxmlformats.org/drawingml/2006/main">
-            <a:off x="95250" y="1038225"/>
+            <a:off x="95250" y="1398225"/>
             <a:ext cx="2724150" cy="238125"/>
           </a:xfrm>
           <a:prstGeom xmlns:a="http://schemas.openxmlformats.org/drawingml/2006/main" prst="rect">
@@ -1358,7 +1358,7 @@
         </p:nvSpPr>
         <p:spPr>
           <a:xfrm xmlns:a="http://schemas.openxmlformats.org/drawingml/2006/main">
-            <a:off x="95250" y="1076325"/>
+            <a:off x="95250" y="1436325"/>
             <a:ext cx="2724150" cy="180975"/>
           </a:xfrm>
           <a:prstGeom xmlns:a="http://schemas.openxmlformats.org/drawingml/2006/main" prst="rect">
@@ -1415,7 +1415,7 @@
         </p:nvSpPr>
         <p:spPr>
           <a:xfrm xmlns:a="http://schemas.openxmlformats.org/drawingml/2006/main">
-            <a:off x="95250" y="1362075"/>
+            <a:off x="95250" y="1722075"/>
             <a:ext cx="2714625" cy="447675"/>
           </a:xfrm>
           <a:prstGeom xmlns:a="http://schemas.openxmlformats.org/drawingml/2006/main" prst="rect">
@@ -1447,7 +1447,7 @@
         </p:nvSpPr>
         <p:spPr>
           <a:xfrm xmlns:a="http://schemas.openxmlformats.org/drawingml/2006/main">
-            <a:off x="161925" y="1390650"/>
+            <a:off x="161925" y="1750650"/>
             <a:ext cx="2581275" cy="381000"/>
           </a:xfrm>
           <a:prstGeom xmlns:a="http://schemas.openxmlformats.org/drawingml/2006/main" prst="rect">
@@ -1527,7 +1527,7 @@
         </p:nvSpPr>
         <p:spPr>
           <a:xfrm xmlns:a="http://schemas.openxmlformats.org/drawingml/2006/main">
-            <a:off x="1428750" y="1809750"/>
+            <a:off x="1428750" y="2169750"/>
             <a:ext cx="9525" cy="361950"/>
           </a:xfrm>
           <a:prstGeom xmlns:a="http://schemas.openxmlformats.org/drawingml/2006/main" prst="rect">
@@ -1557,7 +1557,7 @@
         </p:nvSpPr>
         <p:spPr>
           <a:xfrm xmlns:a="http://schemas.openxmlformats.org/drawingml/2006/main">
-            <a:off x="95250" y="1847850"/>
+            <a:off x="95250" y="2207850"/>
             <a:ext cx="2724150" cy="238125"/>
           </a:xfrm>
           <a:prstGeom xmlns:a="http://schemas.openxmlformats.org/drawingml/2006/main" prst="rect">
@@ -1587,7 +1587,7 @@
         </p:nvSpPr>
         <p:spPr>
           <a:xfrm xmlns:a="http://schemas.openxmlformats.org/drawingml/2006/main">
-            <a:off x="95250" y="1885950"/>
+            <a:off x="95250" y="2245950"/>
             <a:ext cx="2724150" cy="180975"/>
           </a:xfrm>
           <a:prstGeom xmlns:a="http://schemas.openxmlformats.org/drawingml/2006/main" prst="rect">
@@ -1644,7 +1644,7 @@
         </p:nvSpPr>
         <p:spPr>
           <a:xfrm xmlns:a="http://schemas.openxmlformats.org/drawingml/2006/main">
-            <a:off x="95250" y="2171700"/>
+            <a:off x="95250" y="2531700"/>
             <a:ext cx="2714625" cy="447675"/>
           </a:xfrm>
           <a:prstGeom xmlns:a="http://schemas.openxmlformats.org/drawingml/2006/main" prst="rect">
@@ -1676,7 +1676,7 @@
         </p:nvSpPr>
         <p:spPr>
           <a:xfrm xmlns:a="http://schemas.openxmlformats.org/drawingml/2006/main">
-            <a:off x="161925" y="2200275"/>
+            <a:off x="161925" y="2560275"/>
             <a:ext cx="2581275" cy="381000"/>
           </a:xfrm>
           <a:prstGeom xmlns:a="http://schemas.openxmlformats.org/drawingml/2006/main" prst="rect">
@@ -1756,7 +1756,7 @@
         </p:nvSpPr>
         <p:spPr>
           <a:xfrm xmlns:a="http://schemas.openxmlformats.org/drawingml/2006/main">
-            <a:off x="1428750" y="2619375"/>
+            <a:off x="1428750" y="2979375"/>
             <a:ext cx="9525" cy="361950"/>
           </a:xfrm>
           <a:prstGeom xmlns:a="http://schemas.openxmlformats.org/drawingml/2006/main" prst="rect">
@@ -1786,7 +1786,7 @@
         </p:nvSpPr>
         <p:spPr>
           <a:xfrm xmlns:a="http://schemas.openxmlformats.org/drawingml/2006/main">
-            <a:off x="95250" y="2657475"/>
+            <a:off x="95250" y="3017475"/>
             <a:ext cx="2724150" cy="238125"/>
           </a:xfrm>
           <a:prstGeom xmlns:a="http://schemas.openxmlformats.org/drawingml/2006/main" prst="rect">
@@ -1816,7 +1816,7 @@
         </p:nvSpPr>
         <p:spPr>
           <a:xfrm xmlns:a="http://schemas.openxmlformats.org/drawingml/2006/main">
-            <a:off x="95250" y="2695575"/>
+            <a:off x="95250" y="3055575"/>
             <a:ext cx="2724150" cy="180975"/>
           </a:xfrm>
           <a:prstGeom xmlns:a="http://schemas.openxmlformats.org/drawingml/2006/main" prst="rect">
@@ -1873,7 +1873,7 @@
         </p:nvSpPr>
         <p:spPr>
           <a:xfrm xmlns:a="http://schemas.openxmlformats.org/drawingml/2006/main">
-            <a:off x="95250" y="2981325"/>
+            <a:off x="95250" y="3341325"/>
             <a:ext cx="2714625" cy="447675"/>
           </a:xfrm>
           <a:prstGeom xmlns:a="http://schemas.openxmlformats.org/drawingml/2006/main" prst="rect">
@@ -1905,7 +1905,7 @@
         </p:nvSpPr>
         <p:spPr>
           <a:xfrm xmlns:a="http://schemas.openxmlformats.org/drawingml/2006/main">
-            <a:off x="161925" y="3009900"/>
+            <a:off x="161925" y="3369900"/>
             <a:ext cx="2581275" cy="381000"/>
           </a:xfrm>
           <a:prstGeom xmlns:a="http://schemas.openxmlformats.org/drawingml/2006/main" prst="rect">
@@ -1985,7 +1985,7 @@
         </p:nvSpPr>
         <p:spPr>
           <a:xfrm xmlns:a="http://schemas.openxmlformats.org/drawingml/2006/main">
-            <a:off x="1428750" y="3429000"/>
+            <a:off x="1428750" y="3789000"/>
             <a:ext cx="9525" cy="361950"/>
           </a:xfrm>
           <a:prstGeom xmlns:a="http://schemas.openxmlformats.org/drawingml/2006/main" prst="rect">
@@ -2015,7 +2015,7 @@
         </p:nvSpPr>
         <p:spPr>
           <a:xfrm xmlns:a="http://schemas.openxmlformats.org/drawingml/2006/main">
-            <a:off x="95250" y="3467100"/>
+            <a:off x="95250" y="3827100"/>
             <a:ext cx="2724150" cy="238125"/>
           </a:xfrm>
           <a:prstGeom xmlns:a="http://schemas.openxmlformats.org/drawingml/2006/main" prst="rect">
@@ -2045,7 +2045,7 @@
         </p:nvSpPr>
         <p:spPr>
           <a:xfrm xmlns:a="http://schemas.openxmlformats.org/drawingml/2006/main">
-            <a:off x="95250" y="3505200"/>
+            <a:off x="95250" y="3865200"/>
             <a:ext cx="2724150" cy="180975"/>
           </a:xfrm>
           <a:prstGeom xmlns:a="http://schemas.openxmlformats.org/drawingml/2006/main" prst="rect">
@@ -2102,7 +2102,7 @@
         </p:nvSpPr>
         <p:spPr>
           <a:xfrm xmlns:a="http://schemas.openxmlformats.org/drawingml/2006/main">
-            <a:off x="95250" y="3790950"/>
+            <a:off x="95250" y="4150950"/>
             <a:ext cx="2714625" cy="447675"/>
           </a:xfrm>
           <a:prstGeom xmlns:a="http://schemas.openxmlformats.org/drawingml/2006/main" prst="rect">
@@ -2134,7 +2134,7 @@
         </p:nvSpPr>
         <p:spPr>
           <a:xfrm xmlns:a="http://schemas.openxmlformats.org/drawingml/2006/main">
-            <a:off x="161925" y="3819525"/>
+            <a:off x="161925" y="4179525"/>
             <a:ext cx="2581275" cy="381000"/>
           </a:xfrm>
           <a:prstGeom xmlns:a="http://schemas.openxmlformats.org/drawingml/2006/main" prst="rect">
@@ -2214,7 +2214,7 @@
         </p:nvSpPr>
         <p:spPr>
           <a:xfrm xmlns:a="http://schemas.openxmlformats.org/drawingml/2006/main">
-            <a:off x="1428750" y="4238625"/>
+            <a:off x="1428750" y="4598625"/>
             <a:ext cx="9525" cy="361950"/>
           </a:xfrm>
           <a:prstGeom xmlns:a="http://schemas.openxmlformats.org/drawingml/2006/main" prst="rect">
@@ -2244,7 +2244,7 @@
         </p:nvSpPr>
         <p:spPr>
           <a:xfrm xmlns:a="http://schemas.openxmlformats.org/drawingml/2006/main">
-            <a:off x="95250" y="4276725"/>
+            <a:off x="95250" y="4636725"/>
             <a:ext cx="2724150" cy="238125"/>
           </a:xfrm>
           <a:prstGeom xmlns:a="http://schemas.openxmlformats.org/drawingml/2006/main" prst="rect">
@@ -2274,7 +2274,7 @@
         </p:nvSpPr>
         <p:spPr>
           <a:xfrm xmlns:a="http://schemas.openxmlformats.org/drawingml/2006/main">
-            <a:off x="95250" y="4314825"/>
+            <a:off x="95250" y="4674825"/>
             <a:ext cx="2724150" cy="180975"/>
           </a:xfrm>
           <a:prstGeom xmlns:a="http://schemas.openxmlformats.org/drawingml/2006/main" prst="rect">
@@ -2331,7 +2331,7 @@
         </p:nvSpPr>
         <p:spPr>
           <a:xfrm xmlns:a="http://schemas.openxmlformats.org/drawingml/2006/main">
-            <a:off x="95250" y="4600575"/>
+            <a:off x="95250" y="4960575"/>
             <a:ext cx="2714625" cy="447675"/>
           </a:xfrm>
           <a:prstGeom xmlns:a="http://schemas.openxmlformats.org/drawingml/2006/main" prst="rect">
@@ -2363,7 +2363,7 @@
         </p:nvSpPr>
         <p:spPr>
           <a:xfrm xmlns:a="http://schemas.openxmlformats.org/drawingml/2006/main">
-            <a:off x="161925" y="4629150"/>
+            <a:off x="161925" y="4989150"/>
             <a:ext cx="2581275" cy="381000"/>
           </a:xfrm>
           <a:prstGeom xmlns:a="http://schemas.openxmlformats.org/drawingml/2006/main" prst="rect">
@@ -2443,7 +2443,7 @@
         </p:nvSpPr>
         <p:spPr>
           <a:xfrm xmlns:a="http://schemas.openxmlformats.org/drawingml/2006/main">
-            <a:off x="1428750" y="5048250"/>
+            <a:off x="1428750" y="5408250"/>
             <a:ext cx="9525" cy="466725"/>
           </a:xfrm>
           <a:prstGeom xmlns:a="http://schemas.openxmlformats.org/drawingml/2006/main" prst="rect">
@@ -2473,7 +2473,7 @@
         </p:nvSpPr>
         <p:spPr>
           <a:xfrm xmlns:a="http://schemas.openxmlformats.org/drawingml/2006/main">
-            <a:off x="95250" y="5086350"/>
+            <a:off x="95250" y="5446350"/>
             <a:ext cx="2724150" cy="238125"/>
           </a:xfrm>
           <a:prstGeom xmlns:a="http://schemas.openxmlformats.org/drawingml/2006/main" prst="rect">
@@ -2503,7 +2503,7 @@
         </p:nvSpPr>
         <p:spPr>
           <a:xfrm xmlns:a="http://schemas.openxmlformats.org/drawingml/2006/main">
-            <a:off x="95250" y="5124450"/>
+            <a:off x="95250" y="5484450"/>
             <a:ext cx="2724150" cy="180975"/>
           </a:xfrm>
           <a:prstGeom xmlns:a="http://schemas.openxmlformats.org/drawingml/2006/main" prst="rect">
@@ -2560,7 +2560,7 @@
         </p:nvSpPr>
         <p:spPr>
           <a:xfrm xmlns:a="http://schemas.openxmlformats.org/drawingml/2006/main">
-            <a:off x="95250" y="5514975"/>
+            <a:off x="95250" y="5874975"/>
             <a:ext cx="2714625" cy="447675"/>
           </a:xfrm>
           <a:prstGeom xmlns:a="http://schemas.openxmlformats.org/drawingml/2006/main" prst="rect">
@@ -2592,7 +2592,7 @@
         </p:nvSpPr>
         <p:spPr>
           <a:xfrm xmlns:a="http://schemas.openxmlformats.org/drawingml/2006/main">
-            <a:off x="161925" y="5543550"/>
+            <a:off x="161925" y="5903550"/>
             <a:ext cx="2581275" cy="381000"/>
           </a:xfrm>
           <a:prstGeom xmlns:a="http://schemas.openxmlformats.org/drawingml/2006/main" prst="rect">
@@ -2672,7 +2672,7 @@
         </p:nvSpPr>
         <p:spPr>
           <a:xfrm xmlns:a="http://schemas.openxmlformats.org/drawingml/2006/main">
-            <a:off x="3152775" y="552450"/>
+            <a:off x="3152775" y="912450"/>
             <a:ext cx="2714625" cy="552450"/>
           </a:xfrm>
           <a:prstGeom xmlns:a="http://schemas.openxmlformats.org/drawingml/2006/main" prst="rect">
@@ -2704,7 +2704,7 @@
         </p:nvSpPr>
         <p:spPr>
           <a:xfrm xmlns:a="http://schemas.openxmlformats.org/drawingml/2006/main">
-            <a:off x="3209925" y="600075"/>
+            <a:off x="3209925" y="960075"/>
             <a:ext cx="2600325" cy="476250"/>
           </a:xfrm>
           <a:prstGeom xmlns:a="http://schemas.openxmlformats.org/drawingml/2006/main" prst="rect">
@@ -2784,7 +2784,7 @@
         </p:nvSpPr>
         <p:spPr>
           <a:xfrm xmlns:a="http://schemas.openxmlformats.org/drawingml/2006/main">
-            <a:off x="4505325" y="1104900"/>
+            <a:off x="4505325" y="1464900"/>
             <a:ext cx="9525" cy="390525"/>
           </a:xfrm>
           <a:prstGeom xmlns:a="http://schemas.openxmlformats.org/drawingml/2006/main" prst="rect">
@@ -2814,7 +2814,7 @@
         </p:nvSpPr>
         <p:spPr>
           <a:xfrm xmlns:a="http://schemas.openxmlformats.org/drawingml/2006/main">
-            <a:off x="3152775" y="1495425"/>
+            <a:off x="3152775" y="1855425"/>
             <a:ext cx="2714625" cy="552450"/>
           </a:xfrm>
           <a:prstGeom xmlns:a="http://schemas.openxmlformats.org/drawingml/2006/main" prst="rect">
@@ -2846,7 +2846,7 @@
         </p:nvSpPr>
         <p:spPr>
           <a:xfrm xmlns:a="http://schemas.openxmlformats.org/drawingml/2006/main">
-            <a:off x="3209925" y="1543050"/>
+            <a:off x="3209925" y="1903050"/>
             <a:ext cx="2600325" cy="476250"/>
           </a:xfrm>
           <a:prstGeom xmlns:a="http://schemas.openxmlformats.org/drawingml/2006/main" prst="rect">
@@ -2926,7 +2926,7 @@
         </p:nvSpPr>
         <p:spPr>
           <a:xfrm xmlns:a="http://schemas.openxmlformats.org/drawingml/2006/main">
-            <a:off x="4505325" y="2047875"/>
+            <a:off x="4505325" y="2407875"/>
             <a:ext cx="9525" cy="390525"/>
           </a:xfrm>
           <a:prstGeom xmlns:a="http://schemas.openxmlformats.org/drawingml/2006/main" prst="rect">
@@ -2956,7 +2956,7 @@
         </p:nvSpPr>
         <p:spPr>
           <a:xfrm xmlns:a="http://schemas.openxmlformats.org/drawingml/2006/main">
-            <a:off x="3152775" y="2438400"/>
+            <a:off x="3152775" y="2798400"/>
             <a:ext cx="2714625" cy="552450"/>
           </a:xfrm>
           <a:prstGeom xmlns:a="http://schemas.openxmlformats.org/drawingml/2006/main" prst="rect">
@@ -2988,7 +2988,7 @@
         </p:nvSpPr>
         <p:spPr>
           <a:xfrm xmlns:a="http://schemas.openxmlformats.org/drawingml/2006/main">
-            <a:off x="3209925" y="2486025"/>
+            <a:off x="3209925" y="2846025"/>
             <a:ext cx="2600325" cy="476250"/>
           </a:xfrm>
           <a:prstGeom xmlns:a="http://schemas.openxmlformats.org/drawingml/2006/main" prst="rect">
@@ -3068,7 +3068,7 @@
         </p:nvSpPr>
         <p:spPr>
           <a:xfrm xmlns:a="http://schemas.openxmlformats.org/drawingml/2006/main">
-            <a:off x="4505325" y="2990850"/>
+            <a:off x="4505325" y="3350850"/>
             <a:ext cx="9525" cy="390525"/>
           </a:xfrm>
           <a:prstGeom xmlns:a="http://schemas.openxmlformats.org/drawingml/2006/main" prst="rect">
@@ -3098,7 +3098,7 @@
         </p:nvSpPr>
         <p:spPr>
           <a:xfrm xmlns:a="http://schemas.openxmlformats.org/drawingml/2006/main">
-            <a:off x="3152775" y="3381375"/>
+            <a:off x="3152775" y="3741375"/>
             <a:ext cx="2714625" cy="552450"/>
           </a:xfrm>
           <a:prstGeom xmlns:a="http://schemas.openxmlformats.org/drawingml/2006/main" prst="rect">
@@ -3130,7 +3130,7 @@
         </p:nvSpPr>
         <p:spPr>
           <a:xfrm xmlns:a="http://schemas.openxmlformats.org/drawingml/2006/main">
-            <a:off x="3209925" y="3429000"/>
+            <a:off x="3209925" y="3789000"/>
             <a:ext cx="2600325" cy="476250"/>
           </a:xfrm>
           <a:prstGeom xmlns:a="http://schemas.openxmlformats.org/drawingml/2006/main" prst="rect">
@@ -3210,7 +3210,7 @@
         </p:nvSpPr>
         <p:spPr>
           <a:xfrm xmlns:a="http://schemas.openxmlformats.org/drawingml/2006/main">
-            <a:off x="4505325" y="3933825"/>
+            <a:off x="4505325" y="4293825"/>
             <a:ext cx="9525" cy="390525"/>
           </a:xfrm>
           <a:prstGeom xmlns:a="http://schemas.openxmlformats.org/drawingml/2006/main" prst="rect">
@@ -3240,7 +3240,7 @@
         </p:nvSpPr>
         <p:spPr>
           <a:xfrm xmlns:a="http://schemas.openxmlformats.org/drawingml/2006/main">
-            <a:off x="3152775" y="4324350"/>
+            <a:off x="3152775" y="4684350"/>
             <a:ext cx="2714625" cy="552450"/>
           </a:xfrm>
           <a:prstGeom xmlns:a="http://schemas.openxmlformats.org/drawingml/2006/main" prst="rect">
@@ -3272,7 +3272,7 @@
         </p:nvSpPr>
         <p:spPr>
           <a:xfrm xmlns:a="http://schemas.openxmlformats.org/drawingml/2006/main">
-            <a:off x="3209925" y="4371975"/>
+            <a:off x="3209925" y="4731975"/>
             <a:ext cx="2600325" cy="476250"/>
           </a:xfrm>
           <a:prstGeom xmlns:a="http://schemas.openxmlformats.org/drawingml/2006/main" prst="rect">
@@ -3352,7 +3352,7 @@
         </p:nvSpPr>
         <p:spPr>
           <a:xfrm xmlns:a="http://schemas.openxmlformats.org/drawingml/2006/main">
-            <a:off x="4505325" y="4876800"/>
+            <a:off x="4505325" y="5236800"/>
             <a:ext cx="9525" cy="390525"/>
           </a:xfrm>
           <a:prstGeom xmlns:a="http://schemas.openxmlformats.org/drawingml/2006/main" prst="rect">
@@ -3382,7 +3382,7 @@
         </p:nvSpPr>
         <p:spPr>
           <a:xfrm xmlns:a="http://schemas.openxmlformats.org/drawingml/2006/main">
-            <a:off x="3152775" y="5267325"/>
+            <a:off x="3152775" y="5627325"/>
             <a:ext cx="2714625" cy="552450"/>
           </a:xfrm>
           <a:prstGeom xmlns:a="http://schemas.openxmlformats.org/drawingml/2006/main" prst="rect">
@@ -3414,7 +3414,7 @@
         </p:nvSpPr>
         <p:spPr>
           <a:xfrm xmlns:a="http://schemas.openxmlformats.org/drawingml/2006/main">
-            <a:off x="3209925" y="5314950"/>
+            <a:off x="3209925" y="5674950"/>
             <a:ext cx="2600325" cy="476250"/>
           </a:xfrm>
           <a:prstGeom xmlns:a="http://schemas.openxmlformats.org/drawingml/2006/main" prst="rect">
@@ -3494,7 +3494,7 @@
         </p:nvSpPr>
         <p:spPr>
           <a:xfrm xmlns:a="http://schemas.openxmlformats.org/drawingml/2006/main">
-            <a:off x="3171825" y="5953125"/>
+            <a:off x="3171825" y="6313125"/>
             <a:ext cx="2667000" cy="419100"/>
           </a:xfrm>
           <a:prstGeom xmlns:a="http://schemas.openxmlformats.org/drawingml/2006/main" prst="rect">

</xml_diff>